<commit_message>
Polish demo: live URL in docs/deck, Education example shows keyword radar
Add the Render URL to the README, demo script and closing slide; change
the default Education example title so the keyword radar has data to show,
and make its empty-state message accurate (25+ videos from 25+ channels).

Co-Authored-By: Claude Sonnet 5.5 <noreply@anthropic.com>
</commit_message>
<xml_diff>
--- a/deliverables/TA4_YouTube_Content_Strategy_Prediction.pptx
+++ b/deliverables/TA4_YouTube_Content_Strategy_Prediction.pptx
@@ -7451,7 +7451,7 @@
         </p:nvSpPr>
         <p:spPr>
           <a:xfrm>
-            <a:off x="8257032" y="1828800"/>
+            <a:off x="8257032" y="1691640"/>
             <a:ext cx="914400" cy="146304"/>
           </a:xfrm>
           <a:prstGeom prst="rect">
@@ -7492,8 +7492,8 @@
         </p:nvSpPr>
         <p:spPr>
           <a:xfrm>
-            <a:off x="8257032" y="2084832"/>
-            <a:ext cx="2286000" cy="201168"/>
+            <a:off x="8257032" y="1947672"/>
+            <a:ext cx="2697480" cy="201168"/>
           </a:xfrm>
           <a:prstGeom prst="rect">
             <a:avLst/>
@@ -7533,7 +7533,7 @@
         </p:nvSpPr>
         <p:spPr>
           <a:xfrm>
-            <a:off x="8257032" y="2670048"/>
+            <a:off x="8257032" y="2441448"/>
             <a:ext cx="914400" cy="146304"/>
           </a:xfrm>
           <a:prstGeom prst="rect">
@@ -7574,8 +7574,8 @@
         </p:nvSpPr>
         <p:spPr>
           <a:xfrm>
-            <a:off x="8257032" y="2926080"/>
-            <a:ext cx="2286000" cy="201168"/>
+            <a:off x="8257032" y="2697480"/>
+            <a:ext cx="2697480" cy="201168"/>
           </a:xfrm>
           <a:prstGeom prst="rect">
             <a:avLst/>
@@ -7615,7 +7615,7 @@
         </p:nvSpPr>
         <p:spPr>
           <a:xfrm>
-            <a:off x="8257032" y="3511296"/>
+            <a:off x="8257032" y="3191256"/>
             <a:ext cx="914400" cy="146304"/>
           </a:xfrm>
           <a:prstGeom prst="rect">
@@ -7656,8 +7656,8 @@
         </p:nvSpPr>
         <p:spPr>
           <a:xfrm>
-            <a:off x="8257032" y="3767328"/>
-            <a:ext cx="2286000" cy="201168"/>
+            <a:off x="8257032" y="3447288"/>
+            <a:ext cx="2697480" cy="201168"/>
           </a:xfrm>
           <a:prstGeom prst="rect">
             <a:avLst/>
@@ -7692,6 +7692,88 @@
       <p:sp>
         <p:nvSpPr>
           <p:cNvPr id="15" name="Text 13"/>
+          <p:cNvSpPr/>
+          <p:nvPr/>
+        </p:nvSpPr>
+        <p:spPr>
+          <a:xfrm>
+            <a:off x="8257032" y="3941064"/>
+            <a:ext cx="914400" cy="146304"/>
+          </a:xfrm>
+          <a:prstGeom prst="rect">
+            <a:avLst/>
+          </a:prstGeom>
+          <a:noFill/>
+          <a:ln/>
+        </p:spPr>
+        <p:txBody>
+          <a:bodyPr wrap="square" lIns="0" tIns="0" rIns="0" bIns="0" rtlCol="0" anchor="ctr">
+            <a:normAutofit/>
+          </a:bodyPr>
+          <a:lstStyle/>
+          <a:p>
+            <a:pPr algn="l" indent="0" marL="0">
+              <a:buNone/>
+            </a:pPr>
+            <a:r>
+              <a:rPr lang="en-US" sz="950" b="1" spc="90" kern="0" dirty="0">
+                <a:solidFill>
+                  <a:srgbClr val="3D7EFF"/>
+                </a:solidFill>
+                <a:latin typeface="Aptos" pitchFamily="34" charset="0"/>
+                <a:ea typeface="Aptos" pitchFamily="34" charset="-122"/>
+                <a:cs typeface="Aptos" pitchFamily="34" charset="-120"/>
+              </a:rPr>
+              <a:t>LIVE</a:t>
+            </a:r>
+            <a:endParaRPr lang="en-US" sz="950" dirty="0"/>
+          </a:p>
+        </p:txBody>
+      </p:sp>
+      <p:sp>
+        <p:nvSpPr>
+          <p:cNvPr id="16" name="Text 14"/>
+          <p:cNvSpPr/>
+          <p:nvPr/>
+        </p:nvSpPr>
+        <p:spPr>
+          <a:xfrm>
+            <a:off x="8257032" y="4197096"/>
+            <a:ext cx="2697480" cy="201168"/>
+          </a:xfrm>
+          <a:prstGeom prst="rect">
+            <a:avLst/>
+          </a:prstGeom>
+          <a:noFill/>
+          <a:ln/>
+        </p:spPr>
+        <p:txBody>
+          <a:bodyPr wrap="square" lIns="0" tIns="0" rIns="0" bIns="0" rtlCol="0" anchor="ctr">
+            <a:normAutofit/>
+          </a:bodyPr>
+          <a:lstStyle/>
+          <a:p>
+            <a:pPr algn="l" indent="0" marL="0">
+              <a:buNone/>
+            </a:pPr>
+            <a:r>
+              <a:rPr lang="en-US" sz="1020" b="1" dirty="0">
+                <a:solidFill>
+                  <a:srgbClr val="FFFFFF"/>
+                </a:solidFill>
+                <a:latin typeface="Aptos" pitchFamily="34" charset="0"/>
+                <a:ea typeface="Aptos" pitchFamily="34" charset="-122"/>
+                <a:cs typeface="Aptos" pitchFamily="34" charset="-120"/>
+              </a:rPr>
+              <a:t>youtube-strategy-predictor.onrender.com</a:t>
+            </a:r>
+            <a:endParaRPr lang="en-US" sz="1020" dirty="0"/>
+          </a:p>
+        </p:txBody>
+      </p:sp>
+      <p:sp>
+        <p:nvSpPr>
+          <p:cNvPr id="17" name="Text 15"/>
           <p:cNvSpPr/>
           <p:nvPr/>
         </p:nvSpPr>
@@ -7732,7 +7814,7 @@
       </p:sp>
       <p:sp>
         <p:nvSpPr>
-          <p:cNvPr id="16" name="Text 14"/>
+          <p:cNvPr id="18" name="Text 16"/>
           <p:cNvSpPr/>
           <p:nvPr/>
         </p:nvSpPr>
@@ -7773,7 +7855,7 @@
       </p:sp>
       <p:sp>
         <p:nvSpPr>
-          <p:cNvPr id="17" name="Shape 15"/>
+          <p:cNvPr id="19" name="Shape 17"/>
           <p:cNvSpPr/>
           <p:nvPr/>
         </p:nvSpPr>
@@ -7796,7 +7878,7 @@
       </p:sp>
       <p:sp>
         <p:nvSpPr>
-          <p:cNvPr id="18" name="Text 16"/>
+          <p:cNvPr id="20" name="Text 18"/>
           <p:cNvSpPr/>
           <p:nvPr/>
         </p:nvSpPr>
@@ -7837,7 +7919,7 @@
       </p:sp>
       <p:sp>
         <p:nvSpPr>
-          <p:cNvPr id="19" name="Text 17"/>
+          <p:cNvPr id="21" name="Text 19"/>
           <p:cNvSpPr/>
           <p:nvPr/>
         </p:nvSpPr>

</xml_diff>